<commit_message>
Pitch deck: real-hardware screenshot; measured timings
Slide 9 now shows the real-hardware dashboard (Bluetooth bulb cut off, Wi-Fi bulb
isolated by nftables). The timing figures are re-measured on the live devices:
the ESP32 quarantines 1.4-2.0 s after an attack starts (13 runs, median 1.6 s),
and the rest of the hive is immune about 0.2 s after a second report. The old
"~5 s to immunity" mostly measured the pause between button presses.
</commit_message>
<xml_diff>
--- a/docs/Hive-pitch.pptx
+++ b/docs/Hive-pitch.pptx
@@ -117,14 +117,14 @@
   <p:extLst>
     <p:ext uri="{521415D9-36F7-43E2-AB2F-B90AF26B5E84}">
       <p14:sectionLst xmlns:p14="http://schemas.microsoft.com/office/powerpoint/2010/main">
-        <p14:section name="Problem" id="{c82593b1-fb4b-5b4b-eeb2-a2f80ccd5ca0}">
+        <p14:section name="Problem" id="{a2c3364d-d3d5-031b-ba67-176f53fd4bf6}">
           <p14:sldIdLst>
             <p14:sldId id="256"/>
             <p14:sldId id="257"/>
             <p14:sldId id="258"/>
           </p14:sldIdLst>
         </p14:section>
-        <p14:section name="Solution" id="{60bebc11-abe6-3132-762c-268e595b1848}">
+        <p14:section name="Solution" id="{74257d38-3c26-ae67-acb8-ced19fc0f412}">
           <p14:sldIdLst>
             <p14:sldId id="259"/>
             <p14:sldId id="260"/>
@@ -132,13 +132,13 @@
             <p14:sldId id="262"/>
           </p14:sldIdLst>
         </p14:section>
-        <p14:section name="Proof" id="{1c0be5fc-a059-b151-8456-f0ff202aa0f1}">
+        <p14:section name="Proof" id="{7125762a-a8fe-06cf-15d6-ded3079b3cb6}">
           <p14:sldIdLst>
             <p14:sldId id="263"/>
             <p14:sldId id="264"/>
           </p14:sldIdLst>
         </p14:section>
-        <p14:section name="Close" id="{c5ca7a3a-6219-4d89-1f5f-1d623e3a1dc9}">
+        <p14:section name="Close" id="{d4a37777-96dd-a9d1-b09c-8e4213adc40b}">
           <p14:sldIdLst>
             <p14:sldId id="265"/>
             <p14:sldId id="266"/>
@@ -1164,7 +1164,7 @@
           <a:p>
             <a:r>
               <a:rPr lang="en-US" dirty="0"/>
-              <a:t>Every second each device measures five things about its traffic and compares them with what it learned in its first 20 seconds. A tiny autoencoder, trained with numpy on real normal traffic, tries to rebuild them; if it can't, something is wrong. The same 152 bytes of open weights run in Python and on the ESP32.</a:t>
+              <a:t>Every second each device measures five things about its traffic and compares them with what it learned in its first 20 seconds. A tiny autoencoder, trained with numpy on real normal traffic, tries to rebuild them; if it can't, something is wrong. The same 152 bytes of open weights run in Python and on the ESP32. It acts after two abnormal seconds in a row: on the ESP32 that took 1.4 to 2.0 s over 13 runs (median 1.6 s).</a:t>
             </a:r>
             <a:endParaRPr lang="en-US" dirty="0"/>
           </a:p>
@@ -1340,7 +1340,7 @@
           <a:p>
             <a:r>
               <a:rPr lang="en-US" dirty="0"/>
-              <a:t>Hand a judge the keyboard: 1 attacks the ESP32 (watch its LED blink fast), 3 attacks Laptop B, 2 attacks Laptop A, b infects the Wi-Fi bulb, t the Bluetooth bulb, c attacks the cure, r resets. Press Reset once before starting. Backup video: docs/demo-backup-simulation.mp4.</a:t>
+              <a:t>Hand a judge the keyboard: 1 attacks the ESP32 (watch its LED blink fast), 3 attacks Laptop B, 2 attacks Laptop A, b infects the Wi-Fi bulb, t the Bluetooth bulb, c attacks the cure, r resets. Press Reset once before starting. Backup videos: docs/demo-backup-hardware.mp4 (these devices) and docs/demo-backup-simulation.mp4 (one laptop).</a:t>
             </a:r>
             <a:endParaRPr lang="en-US" dirty="0"/>
           </a:p>
@@ -1428,7 +1428,7 @@
           <a:p>
             <a:r>
               <a:rPr lang="en-US" dirty="0"/>
-              <a:t>These numbers come from our own devices, not a simulation. The time to immunity includes the gap between button presses. Testing on hardware found a real bug: the ESP32's network library went deaf after one large packet. It's fixed and covered by a test.</a:t>
+              <a:t>These numbers come from our own devices, not a simulation. The ESP32 needed 1.4 to 2.0 s over 13 runs (median 1.6 s). Once a second device reports the attacker, the rest of the hive is immune about 0.2 s later. The dashboard's timer runs from the first attack to the last device, so it also counts the gap between button presses (3.5 to 3.8 s when pressed back to back). Testing on hardware found a real bug: the ESP32's network library went deaf after one large packet. It's fixed and covered by a test.</a:t>
             </a:r>
             <a:endParaRPr lang="en-US" dirty="0"/>
           </a:p>
@@ -7446,7 +7446,7 @@
                   <a:schemeClr val="accent1"/>
                 </a:solidFill>
               </a:rPr>
-              <a:t>~1.5 s</a:t>
+              <a:t>~1.6 s</a:t>
             </a:r>
             <a:endParaRPr lang="en-US" sz="4000" dirty="0"/>
           </a:p>
@@ -11684,7 +11684,7 @@
                   <a:schemeClr val="accent5"/>
                 </a:solidFill>
               </a:rPr>
-              <a:t>The live dashboard, mid-demo, on real devices</a:t>
+              <a:t>The live dashboard on real devices (its timer also counts the pauses between button presses)</a:t>
             </a:r>
             <a:endParaRPr lang="en-US" sz="1200" dirty="0"/>
           </a:p>
@@ -11720,7 +11720,7 @@
                   <a:schemeClr val="accent1"/>
                 </a:solidFill>
               </a:rPr>
-              <a:t>~1.5 s</a:t>
+              <a:t>~1.6 s</a:t>
             </a:r>
             <a:endParaRPr lang="en-US" sz="2800" dirty="0"/>
           </a:p>
@@ -11792,7 +11792,7 @@
                   <a:schemeClr val="accent1"/>
                 </a:solidFill>
               </a:rPr>
-              <a:t>~6 s</a:t>
+              <a:t>0.2 s</a:t>
             </a:r>
             <a:endParaRPr lang="en-US" sz="2800" dirty="0"/>
           </a:p>
@@ -11828,7 +11828,7 @@
                   <a:schemeClr val="bg2"/>
                 </a:solidFill>
               </a:rPr>
-              <a:t>until every device is immune</a:t>
+              <a:t>from the 2nd report to every device immune</a:t>
             </a:r>
             <a:endParaRPr lang="en-US" sz="1500" dirty="0"/>
           </a:p>

</xml_diff>